<commit_message>
feat: restore PedestrianTracker identity-review demo
</commit_message>
<xml_diff>
--- a/docs/architecture/effiped-architecture.pptx
+++ b/docs/architecture/effiped-architecture.pptx
@@ -2,13 +2,13 @@
 <file path=ppt/presentation.xml><?xml version="1.0" encoding="utf-8"?>
 <p:presentation xmlns:p="http://schemas.openxmlformats.org/presentationml/2006/main">
   <p:sldMasterIdLst>
-    <p:sldMasterId xmlns:r="http://schemas.openxmlformats.org/officeDocument/2006/relationships" id="2147483648" r:id="R985965567851485b"/>
+    <p:sldMasterId xmlns:r="http://schemas.openxmlformats.org/officeDocument/2006/relationships" id="2147483648" r:id="R7a70475cc8504178"/>
   </p:sldMasterIdLst>
   <p:notesMasterIdLst>
-    <p:notesMasterId xmlns:r="http://schemas.openxmlformats.org/officeDocument/2006/relationships" r:id="R78e09e8821b946cc"/>
+    <p:notesMasterId xmlns:r="http://schemas.openxmlformats.org/officeDocument/2006/relationships" r:id="R177627860b1042bd"/>
   </p:notesMasterIdLst>
   <p:sldIdLst>
-    <p:sldId xmlns:r="http://schemas.openxmlformats.org/officeDocument/2006/relationships" id="256" r:id="R8e52244622d445a2"/>
+    <p:sldId xmlns:r="http://schemas.openxmlformats.org/officeDocument/2006/relationships" id="256" r:id="Ra46c8a6eb304482e"/>
   </p:sldIdLst>
   <p:sldSz cx="12192000" cy="6858000"/>
   <p:notesSz cx="6858000" cy="9144000"/>
@@ -447,22 +447,17 @@
           </a:p>
           <a:p xmlns:a="http://schemas.openxmlformats.org/drawingml/2006/main">
             <a:r>
-              <a:t>- EffiPed implementation and configurations: this repository, src/effiped and configs/contest.</a:t>
-            </a:r>
-          </a:p>
-          <a:p xmlns:a="http://schemas.openxmlformats.org/drawingml/2006/main">
-            <a:r>
-              <a:t>- Evidence fixture: research/results/summary.json.</a:t>
-            </a:r>
-          </a:p>
-          <a:p xmlns:a="http://schemas.openxmlformats.org/drawingml/2006/main">
-            <a:r>
-              <a:t>- P-DESTRE paper: https://arxiv.org/abs/2004.02782</a:t>
-            </a:r>
-          </a:p>
-          <a:p xmlns:a="http://schemas.openxmlformats.org/drawingml/2006/main">
-            <a:r>
-              <a:t>- Diagram equations are editable PowerPoint text using Cambria Math; notation summarizes implemented losses and retrieval.</a:t>
+              <a:t>- Project architecture and model configuration: repository source and configs/system/effiped-tier1.yaml</a:t>
+            </a:r>
+          </a:p>
+          <a:p xmlns:a="http://schemas.openxmlformats.org/drawingml/2006/main">
+            <a:r>
+              <a:t>- Aggregate evidence: research/results/summary.json</a:t>
+            </a:r>
+          </a:p>
+          <a:p xmlns:a="http://schemas.openxmlformats.org/drawingml/2006/main">
+            <a:r>
+              <a:t>[/Sources]</a:t>
             </a:r>
           </a:p>
         </p:txBody>
@@ -530,7 +525,7 @@
   </p:cSld>
   <p:clrMap bg1="lt1" tx1="dk1" bg2="lt2" tx2="dk2" accent1="accent1" accent2="accent2" accent3="accent3" accent4="accent4" accent5="accent5" accent6="accent6" hlink="hlink" folHlink="folHlink"/>
   <p:sldLayoutIdLst>
-    <p:sldLayoutId xmlns:r="http://schemas.openxmlformats.org/officeDocument/2006/relationships" id="2147483649" r:id="Ra3b5543d4cb645ca"/>
+    <p:sldLayoutId xmlns:r="http://schemas.openxmlformats.org/officeDocument/2006/relationships" id="2147483649" r:id="R29a3d2c9a4f24a7c"/>
   </p:sldLayoutIdLst>
   <p:txStyles>
     <p:titleStyle>
@@ -3699,6 +3694,7 @@
           <a:lstStyle xmlns:a="http://schemas.openxmlformats.org/drawingml/2006/main"/>
           <a:p xmlns:a="http://schemas.openxmlformats.org/drawingml/2006/main">
             <a:pPr algn="l">
+              <a:buNone/>
               <a:defRPr sz="750" b="1">
                 <a:solidFill>
                   <a:srgbClr val="24E6BD"/>
@@ -3749,6 +3745,7 @@
           <a:lstStyle xmlns:a="http://schemas.openxmlformats.org/drawingml/2006/main"/>
           <a:p xmlns:a="http://schemas.openxmlformats.org/drawingml/2006/main">
             <a:pPr algn="l">
+              <a:buNone/>
               <a:defRPr sz="1650" b="1">
                 <a:solidFill>
                   <a:srgbClr val="F0FAF8"/>
@@ -3805,6 +3802,7 @@
           <a:lstStyle xmlns:a="http://schemas.openxmlformats.org/drawingml/2006/main"/>
           <a:p xmlns:a="http://schemas.openxmlformats.org/drawingml/2006/main">
             <a:pPr algn="ctr">
+              <a:buNone/>
               <a:defRPr sz="525" b="1">
                 <a:solidFill>
                   <a:srgbClr val="06100F"/>
@@ -3817,7 +3815,7 @@
                   <a:srgbClr val="06100F"/>
                 </a:solidFill>
               </a:rPr>
-              <a:t>3RD PRIZE · SIPC 2026</a:t>
+              <a:t>DETECTION · TRACKING · RETRIEVAL</a:t>
             </a:r>
           </a:p>
         </p:txBody>
@@ -3855,6 +3853,7 @@
           <a:lstStyle xmlns:a="http://schemas.openxmlformats.org/drawingml/2006/main"/>
           <a:p xmlns:a="http://schemas.openxmlformats.org/drawingml/2006/main">
             <a:pPr algn="l">
+              <a:buNone/>
               <a:defRPr sz="600" b="1">
                 <a:solidFill>
                   <a:srgbClr val="89A59F"/>
@@ -3940,6 +3939,7 @@
           <a:lstStyle xmlns:a="http://schemas.openxmlformats.org/drawingml/2006/main"/>
           <a:p xmlns:a="http://schemas.openxmlformats.org/drawingml/2006/main">
             <a:pPr algn="ctr">
+              <a:buNone/>
               <a:defRPr sz="900" b="1">
                 <a:solidFill>
                   <a:srgbClr val="F0FAF8"/>
@@ -3990,6 +3990,7 @@
           <a:lstStyle xmlns:a="http://schemas.openxmlformats.org/drawingml/2006/main"/>
           <a:p xmlns:a="http://schemas.openxmlformats.org/drawingml/2006/main">
             <a:pPr algn="ctr">
+              <a:buNone/>
               <a:defRPr sz="525" b="0">
                 <a:solidFill>
                   <a:srgbClr val="89A59F"/>
@@ -4108,6 +4109,7 @@
           <a:lstStyle xmlns:a="http://schemas.openxmlformats.org/drawingml/2006/main"/>
           <a:p xmlns:a="http://schemas.openxmlformats.org/drawingml/2006/main">
             <a:pPr algn="ctr">
+              <a:buNone/>
               <a:defRPr sz="900" b="1">
                 <a:solidFill>
                   <a:srgbClr val="F0FAF8"/>
@@ -4158,6 +4160,7 @@
           <a:lstStyle xmlns:a="http://schemas.openxmlformats.org/drawingml/2006/main"/>
           <a:p xmlns:a="http://schemas.openxmlformats.org/drawingml/2006/main">
             <a:pPr algn="ctr">
+              <a:buNone/>
               <a:defRPr sz="525" b="0">
                 <a:solidFill>
                   <a:srgbClr val="89A59F"/>
@@ -4276,6 +4279,7 @@
           <a:lstStyle xmlns:a="http://schemas.openxmlformats.org/drawingml/2006/main"/>
           <a:p xmlns:a="http://schemas.openxmlformats.org/drawingml/2006/main">
             <a:pPr algn="ctr">
+              <a:buNone/>
               <a:defRPr sz="900" b="1">
                 <a:solidFill>
                   <a:srgbClr val="F0FAF8"/>
@@ -4326,6 +4330,7 @@
           <a:lstStyle xmlns:a="http://schemas.openxmlformats.org/drawingml/2006/main"/>
           <a:p xmlns:a="http://schemas.openxmlformats.org/drawingml/2006/main">
             <a:pPr algn="ctr">
+              <a:buNone/>
               <a:defRPr sz="525" b="0">
                 <a:solidFill>
                   <a:srgbClr val="89A59F"/>
@@ -4444,6 +4449,7 @@
           <a:lstStyle xmlns:a="http://schemas.openxmlformats.org/drawingml/2006/main"/>
           <a:p xmlns:a="http://schemas.openxmlformats.org/drawingml/2006/main">
             <a:pPr algn="ctr">
+              <a:buNone/>
               <a:defRPr sz="900" b="1">
                 <a:solidFill>
                   <a:srgbClr val="F0FAF8"/>
@@ -4494,6 +4500,7 @@
           <a:lstStyle xmlns:a="http://schemas.openxmlformats.org/drawingml/2006/main"/>
           <a:p xmlns:a="http://schemas.openxmlformats.org/drawingml/2006/main">
             <a:pPr algn="ctr">
+              <a:buNone/>
               <a:defRPr sz="525" b="0">
                 <a:solidFill>
                   <a:srgbClr val="89A59F"/>
@@ -4612,6 +4619,7 @@
           <a:lstStyle xmlns:a="http://schemas.openxmlformats.org/drawingml/2006/main"/>
           <a:p xmlns:a="http://schemas.openxmlformats.org/drawingml/2006/main">
             <a:pPr algn="l">
+              <a:buNone/>
               <a:defRPr sz="750" b="1">
                 <a:solidFill>
                   <a:srgbClr val="F0FAF8"/>
@@ -4662,6 +4670,7 @@
           <a:lstStyle xmlns:a="http://schemas.openxmlformats.org/drawingml/2006/main"/>
           <a:p xmlns:a="http://schemas.openxmlformats.org/drawingml/2006/main">
             <a:pPr algn="l">
+              <a:buNone/>
               <a:defRPr sz="563" b="0">
                 <a:solidFill>
                   <a:srgbClr val="89A59F"/>
@@ -4679,6 +4688,7 @@
           </a:p>
           <a:p xmlns:a="http://schemas.openxmlformats.org/drawingml/2006/main">
             <a:pPr algn="l">
+              <a:buNone/>
               <a:defRPr sz="563" b="0">
                 <a:solidFill>
                   <a:srgbClr val="89A59F"/>
@@ -4729,6 +4739,7 @@
           <a:lstStyle xmlns:a="http://schemas.openxmlformats.org/drawingml/2006/main"/>
           <a:p xmlns:a="http://schemas.openxmlformats.org/drawingml/2006/main">
             <a:pPr algn="l">
+              <a:buNone/>
               <a:defRPr sz="600" b="1">
                 <a:solidFill>
                   <a:srgbClr val="89A59F"/>
@@ -4814,6 +4825,7 @@
           <a:lstStyle xmlns:a="http://schemas.openxmlformats.org/drawingml/2006/main"/>
           <a:p xmlns:a="http://schemas.openxmlformats.org/drawingml/2006/main">
             <a:pPr algn="l">
+              <a:buNone/>
               <a:defRPr sz="825" b="1">
                 <a:solidFill>
                   <a:srgbClr val="F0FAF8"/>
@@ -4899,6 +4911,7 @@
           <a:lstStyle xmlns:a="http://schemas.openxmlformats.org/drawingml/2006/main"/>
           <a:p xmlns:a="http://schemas.openxmlformats.org/drawingml/2006/main">
             <a:pPr algn="ctr">
+              <a:buNone/>
               <a:defRPr sz="503" b="0">
                 <a:solidFill>
                   <a:srgbClr val="F0FAF8"/>
@@ -4984,6 +4997,7 @@
           <a:lstStyle xmlns:a="http://schemas.openxmlformats.org/drawingml/2006/main"/>
           <a:p xmlns:a="http://schemas.openxmlformats.org/drawingml/2006/main">
             <a:pPr algn="ctr">
+              <a:buNone/>
               <a:defRPr sz="503" b="0">
                 <a:solidFill>
                   <a:srgbClr val="F0FAF8"/>
@@ -5069,6 +5083,7 @@
           <a:lstStyle xmlns:a="http://schemas.openxmlformats.org/drawingml/2006/main"/>
           <a:p xmlns:a="http://schemas.openxmlformats.org/drawingml/2006/main">
             <a:pPr algn="ctr">
+              <a:buNone/>
               <a:defRPr sz="503" b="0">
                 <a:solidFill>
                   <a:srgbClr val="F0FAF8"/>
@@ -5154,6 +5169,7 @@
           <a:lstStyle xmlns:a="http://schemas.openxmlformats.org/drawingml/2006/main"/>
           <a:p xmlns:a="http://schemas.openxmlformats.org/drawingml/2006/main">
             <a:pPr algn="ctr">
+              <a:buNone/>
               <a:defRPr sz="503" b="0">
                 <a:solidFill>
                   <a:srgbClr val="F0FAF8"/>
@@ -5239,6 +5255,7 @@
           <a:lstStyle xmlns:a="http://schemas.openxmlformats.org/drawingml/2006/main"/>
           <a:p xmlns:a="http://schemas.openxmlformats.org/drawingml/2006/main">
             <a:pPr algn="l">
+              <a:buNone/>
               <a:defRPr sz="825" b="1">
                 <a:solidFill>
                   <a:srgbClr val="F0FAF8"/>
@@ -5289,6 +5306,7 @@
           <a:lstStyle xmlns:a="http://schemas.openxmlformats.org/drawingml/2006/main"/>
           <a:p xmlns:a="http://schemas.openxmlformats.org/drawingml/2006/main">
             <a:pPr algn="l">
+              <a:buNone/>
               <a:defRPr sz="615" b="0">
                 <a:solidFill>
                   <a:srgbClr val="89A59F"/>
@@ -5306,6 +5324,7 @@
           </a:p>
           <a:p xmlns:a="http://schemas.openxmlformats.org/drawingml/2006/main">
             <a:pPr algn="l">
+              <a:buNone/>
               <a:defRPr sz="615" b="0">
                 <a:solidFill>
                   <a:srgbClr val="89A59F"/>
@@ -5323,6 +5342,7 @@
           </a:p>
           <a:p xmlns:a="http://schemas.openxmlformats.org/drawingml/2006/main">
             <a:pPr algn="l">
+              <a:buNone/>
               <a:defRPr sz="615" b="0">
                 <a:solidFill>
                   <a:srgbClr val="89A59F"/>
@@ -5373,6 +5393,7 @@
           <a:lstStyle xmlns:a="http://schemas.openxmlformats.org/drawingml/2006/main"/>
           <a:p xmlns:a="http://schemas.openxmlformats.org/drawingml/2006/main">
             <a:pPr algn="l">
+              <a:buNone/>
               <a:defRPr sz="600" b="1">
                 <a:solidFill>
                   <a:srgbClr val="89A59F"/>
@@ -5458,6 +5479,7 @@
           <a:lstStyle xmlns:a="http://schemas.openxmlformats.org/drawingml/2006/main"/>
           <a:p xmlns:a="http://schemas.openxmlformats.org/drawingml/2006/main">
             <a:pPr algn="l">
+              <a:buNone/>
               <a:defRPr sz="825" b="1">
                 <a:solidFill>
                   <a:srgbClr val="F0FAF8"/>
@@ -5508,6 +5530,7 @@
           <a:lstStyle xmlns:a="http://schemas.openxmlformats.org/drawingml/2006/main"/>
           <a:p xmlns:a="http://schemas.openxmlformats.org/drawingml/2006/main">
             <a:pPr algn="l">
+              <a:buNone/>
               <a:defRPr sz="607" b="0">
                 <a:solidFill>
                   <a:srgbClr val="89A59F"/>
@@ -5525,6 +5548,7 @@
           </a:p>
           <a:p xmlns:a="http://schemas.openxmlformats.org/drawingml/2006/main">
             <a:pPr algn="l">
+              <a:buNone/>
               <a:defRPr sz="607" b="0">
                 <a:solidFill>
                   <a:srgbClr val="89A59F"/>
@@ -5542,6 +5566,7 @@
           </a:p>
           <a:p xmlns:a="http://schemas.openxmlformats.org/drawingml/2006/main">
             <a:pPr algn="l">
+              <a:buNone/>
               <a:defRPr sz="607" b="0">
                 <a:solidFill>
                   <a:srgbClr val="89A59F"/>
@@ -5559,6 +5584,7 @@
           </a:p>
           <a:p xmlns:a="http://schemas.openxmlformats.org/drawingml/2006/main">
             <a:pPr algn="l">
+              <a:buNone/>
               <a:defRPr sz="607" b="0">
                 <a:solidFill>
                   <a:srgbClr val="89A59F"/>
@@ -5609,6 +5635,7 @@
           <a:lstStyle xmlns:a="http://schemas.openxmlformats.org/drawingml/2006/main"/>
           <a:p xmlns:a="http://schemas.openxmlformats.org/drawingml/2006/main">
             <a:pPr algn="ctr">
+              <a:buNone/>
               <a:defRPr sz="600" b="0">
                 <a:solidFill>
                   <a:srgbClr val="8CF8DF"/>
@@ -5626,6 +5653,7 @@
           </a:p>
           <a:p xmlns:a="http://schemas.openxmlformats.org/drawingml/2006/main">
             <a:pPr algn="ctr">
+              <a:buNone/>
               <a:defRPr sz="600" b="0">
                 <a:solidFill>
                   <a:srgbClr val="8CF8DF"/>
@@ -5676,6 +5704,7 @@
           <a:lstStyle xmlns:a="http://schemas.openxmlformats.org/drawingml/2006/main"/>
           <a:p xmlns:a="http://schemas.openxmlformats.org/drawingml/2006/main">
             <a:pPr algn="l">
+              <a:buNone/>
               <a:defRPr sz="600" b="1">
                 <a:solidFill>
                   <a:srgbClr val="89A59F"/>
@@ -5761,6 +5790,7 @@
           <a:lstStyle xmlns:a="http://schemas.openxmlformats.org/drawingml/2006/main"/>
           <a:p xmlns:a="http://schemas.openxmlformats.org/drawingml/2006/main">
             <a:pPr algn="l">
+              <a:buNone/>
               <a:defRPr sz="825" b="1">
                 <a:solidFill>
                   <a:srgbClr val="F0FAF8"/>
@@ -5811,6 +5841,7 @@
           <a:lstStyle xmlns:a="http://schemas.openxmlformats.org/drawingml/2006/main"/>
           <a:p xmlns:a="http://schemas.openxmlformats.org/drawingml/2006/main">
             <a:pPr algn="l">
+              <a:buNone/>
               <a:defRPr sz="653" b="0">
                 <a:solidFill>
                   <a:srgbClr val="89A59F"/>
@@ -5828,6 +5859,7 @@
           </a:p>
           <a:p xmlns:a="http://schemas.openxmlformats.org/drawingml/2006/main">
             <a:pPr algn="l">
+              <a:buNone/>
               <a:defRPr sz="653" b="0">
                 <a:solidFill>
                   <a:srgbClr val="89A59F"/>
@@ -5845,6 +5877,7 @@
           </a:p>
           <a:p xmlns:a="http://schemas.openxmlformats.org/drawingml/2006/main">
             <a:pPr algn="l">
+              <a:buNone/>
               <a:defRPr sz="653" b="0">
                 <a:solidFill>
                   <a:srgbClr val="89A59F"/>
@@ -5862,6 +5895,7 @@
           </a:p>
           <a:p xmlns:a="http://schemas.openxmlformats.org/drawingml/2006/main">
             <a:pPr algn="l">
+              <a:buNone/>
               <a:defRPr sz="653" b="0">
                 <a:solidFill>
                   <a:srgbClr val="89A59F"/>
@@ -5947,6 +5981,7 @@
           <a:lstStyle xmlns:a="http://schemas.openxmlformats.org/drawingml/2006/main"/>
           <a:p xmlns:a="http://schemas.openxmlformats.org/drawingml/2006/main">
             <a:pPr algn="l">
+              <a:buNone/>
               <a:defRPr sz="825" b="1">
                 <a:solidFill>
                   <a:srgbClr val="F0FAF8"/>
@@ -5997,6 +6032,7 @@
           <a:lstStyle xmlns:a="http://schemas.openxmlformats.org/drawingml/2006/main"/>
           <a:p xmlns:a="http://schemas.openxmlformats.org/drawingml/2006/main">
             <a:pPr algn="l">
+              <a:buNone/>
               <a:defRPr sz="630" b="0">
                 <a:solidFill>
                   <a:srgbClr val="89A59F"/>
@@ -6014,6 +6050,7 @@
           </a:p>
           <a:p xmlns:a="http://schemas.openxmlformats.org/drawingml/2006/main">
             <a:pPr algn="l">
+              <a:buNone/>
               <a:defRPr sz="630" b="0">
                 <a:solidFill>
                   <a:srgbClr val="89A59F"/>
@@ -6196,6 +6233,7 @@
           <a:lstStyle xmlns:a="http://schemas.openxmlformats.org/drawingml/2006/main"/>
           <a:p xmlns:a="http://schemas.openxmlformats.org/drawingml/2006/main">
             <a:pPr algn="l">
+              <a:buNone/>
               <a:defRPr sz="600" b="1">
                 <a:solidFill>
                   <a:srgbClr val="89A59F"/>
@@ -6281,6 +6319,7 @@
           <a:lstStyle xmlns:a="http://schemas.openxmlformats.org/drawingml/2006/main"/>
           <a:p xmlns:a="http://schemas.openxmlformats.org/drawingml/2006/main">
             <a:pPr algn="l">
+              <a:buNone/>
               <a:defRPr sz="825" b="1">
                 <a:solidFill>
                   <a:srgbClr val="F0FAF8"/>
@@ -6331,6 +6370,7 @@
           <a:lstStyle xmlns:a="http://schemas.openxmlformats.org/drawingml/2006/main"/>
           <a:p xmlns:a="http://schemas.openxmlformats.org/drawingml/2006/main">
             <a:pPr algn="l">
+              <a:buNone/>
               <a:defRPr sz="630" b="0">
                 <a:solidFill>
                   <a:srgbClr val="89A59F"/>
@@ -6348,6 +6388,7 @@
           </a:p>
           <a:p xmlns:a="http://schemas.openxmlformats.org/drawingml/2006/main">
             <a:pPr algn="l">
+              <a:buNone/>
               <a:defRPr sz="630" b="0">
                 <a:solidFill>
                   <a:srgbClr val="89A59F"/>
@@ -6365,6 +6406,7 @@
           </a:p>
           <a:p xmlns:a="http://schemas.openxmlformats.org/drawingml/2006/main">
             <a:pPr algn="l">
+              <a:buNone/>
               <a:defRPr sz="630" b="0">
                 <a:solidFill>
                   <a:srgbClr val="89A59F"/>
@@ -6382,6 +6424,7 @@
           </a:p>
           <a:p xmlns:a="http://schemas.openxmlformats.org/drawingml/2006/main">
             <a:pPr algn="l">
+              <a:buNone/>
               <a:defRPr sz="630" b="0">
                 <a:solidFill>
                   <a:srgbClr val="89A59F"/>
@@ -6556,6 +6599,7 @@
           <a:lstStyle xmlns:a="http://schemas.openxmlformats.org/drawingml/2006/main"/>
           <a:p xmlns:a="http://schemas.openxmlformats.org/drawingml/2006/main">
             <a:pPr algn="l">
+              <a:buNone/>
               <a:defRPr sz="600" b="1">
                 <a:solidFill>
                   <a:srgbClr val="89A59F"/>
@@ -6641,6 +6685,7 @@
           <a:lstStyle xmlns:a="http://schemas.openxmlformats.org/drawingml/2006/main"/>
           <a:p xmlns:a="http://schemas.openxmlformats.org/drawingml/2006/main">
             <a:pPr algn="l">
+              <a:buNone/>
               <a:defRPr sz="825" b="1">
                 <a:solidFill>
                   <a:srgbClr val="F0FAF8"/>
@@ -6691,6 +6736,7 @@
           <a:lstStyle xmlns:a="http://schemas.openxmlformats.org/drawingml/2006/main"/>
           <a:p xmlns:a="http://schemas.openxmlformats.org/drawingml/2006/main">
             <a:pPr algn="l">
+              <a:buNone/>
               <a:defRPr sz="607" b="0">
                 <a:solidFill>
                   <a:srgbClr val="89A59F"/>
@@ -6708,6 +6754,7 @@
           </a:p>
           <a:p xmlns:a="http://schemas.openxmlformats.org/drawingml/2006/main">
             <a:pPr algn="l">
+              <a:buNone/>
               <a:defRPr sz="607" b="0">
                 <a:solidFill>
                   <a:srgbClr val="89A59F"/>
@@ -6725,6 +6772,7 @@
           </a:p>
           <a:p xmlns:a="http://schemas.openxmlformats.org/drawingml/2006/main">
             <a:pPr algn="l">
+              <a:buNone/>
               <a:defRPr sz="607" b="0">
                 <a:solidFill>
                   <a:srgbClr val="89A59F"/>
@@ -6742,6 +6790,7 @@
           </a:p>
           <a:p xmlns:a="http://schemas.openxmlformats.org/drawingml/2006/main">
             <a:pPr algn="l">
+              <a:buNone/>
               <a:defRPr sz="607" b="0">
                 <a:solidFill>
                   <a:srgbClr val="89A59F"/>
@@ -6827,6 +6876,7 @@
           <a:lstStyle xmlns:a="http://schemas.openxmlformats.org/drawingml/2006/main"/>
           <a:p xmlns:a="http://schemas.openxmlformats.org/drawingml/2006/main">
             <a:pPr algn="ctr">
+              <a:buNone/>
               <a:defRPr sz="713" b="1">
                 <a:solidFill>
                   <a:srgbClr val="F0FAF8"/>
@@ -6877,6 +6927,7 @@
           <a:lstStyle xmlns:a="http://schemas.openxmlformats.org/drawingml/2006/main"/>
           <a:p xmlns:a="http://schemas.openxmlformats.org/drawingml/2006/main">
             <a:pPr algn="ctr">
+              <a:buNone/>
               <a:defRPr sz="555" b="0">
                 <a:solidFill>
                   <a:srgbClr val="89A59F"/>
@@ -6894,6 +6945,7 @@
           </a:p>
           <a:p xmlns:a="http://schemas.openxmlformats.org/drawingml/2006/main">
             <a:pPr algn="ctr">
+              <a:buNone/>
               <a:defRPr sz="555" b="0">
                 <a:solidFill>
                   <a:srgbClr val="89A59F"/>
@@ -6911,6 +6963,7 @@
           </a:p>
           <a:p xmlns:a="http://schemas.openxmlformats.org/drawingml/2006/main">
             <a:pPr algn="ctr">
+              <a:buNone/>
               <a:defRPr sz="555" b="0">
                 <a:solidFill>
                   <a:srgbClr val="89A59F"/>
@@ -6961,6 +7014,7 @@
           <a:lstStyle xmlns:a="http://schemas.openxmlformats.org/drawingml/2006/main"/>
           <a:p xmlns:a="http://schemas.openxmlformats.org/drawingml/2006/main">
             <a:pPr algn="l">
+              <a:buNone/>
               <a:defRPr sz="600" b="1">
                 <a:solidFill>
                   <a:srgbClr val="89A59F"/>
@@ -7046,6 +7100,7 @@
           <a:lstStyle xmlns:a="http://schemas.openxmlformats.org/drawingml/2006/main"/>
           <a:p xmlns:a="http://schemas.openxmlformats.org/drawingml/2006/main">
             <a:pPr algn="l">
+              <a:buNone/>
               <a:defRPr sz="750" b="1">
                 <a:solidFill>
                   <a:srgbClr val="F0FAF8"/>
@@ -7096,6 +7151,7 @@
           <a:lstStyle xmlns:a="http://schemas.openxmlformats.org/drawingml/2006/main"/>
           <a:p xmlns:a="http://schemas.openxmlformats.org/drawingml/2006/main">
             <a:pPr algn="l">
+              <a:buNone/>
               <a:defRPr sz="600" b="0">
                 <a:solidFill>
                   <a:srgbClr val="89A59F"/>
@@ -7113,6 +7169,7 @@
           </a:p>
           <a:p xmlns:a="http://schemas.openxmlformats.org/drawingml/2006/main">
             <a:pPr algn="l">
+              <a:buNone/>
               <a:defRPr sz="600" b="0">
                 <a:solidFill>
                   <a:srgbClr val="89A59F"/>
@@ -7198,6 +7255,7 @@
           <a:lstStyle xmlns:a="http://schemas.openxmlformats.org/drawingml/2006/main"/>
           <a:p xmlns:a="http://schemas.openxmlformats.org/drawingml/2006/main">
             <a:pPr algn="l">
+              <a:buNone/>
               <a:defRPr sz="750" b="1">
                 <a:solidFill>
                   <a:srgbClr val="F0FAF8"/>
@@ -7248,6 +7306,7 @@
           <a:lstStyle xmlns:a="http://schemas.openxmlformats.org/drawingml/2006/main"/>
           <a:p xmlns:a="http://schemas.openxmlformats.org/drawingml/2006/main">
             <a:pPr algn="l">
+              <a:buNone/>
               <a:defRPr sz="600" b="0">
                 <a:solidFill>
                   <a:srgbClr val="89A59F"/>
@@ -7265,6 +7324,7 @@
           </a:p>
           <a:p xmlns:a="http://schemas.openxmlformats.org/drawingml/2006/main">
             <a:pPr algn="l">
+              <a:buNone/>
               <a:defRPr sz="600" b="0">
                 <a:solidFill>
                   <a:srgbClr val="89A59F"/>
@@ -7350,6 +7410,7 @@
           <a:lstStyle xmlns:a="http://schemas.openxmlformats.org/drawingml/2006/main"/>
           <a:p xmlns:a="http://schemas.openxmlformats.org/drawingml/2006/main">
             <a:pPr algn="l">
+              <a:buNone/>
               <a:defRPr sz="690" b="1">
                 <a:solidFill>
                   <a:srgbClr val="F0FAF8"/>
@@ -7400,6 +7461,7 @@
           <a:lstStyle xmlns:a="http://schemas.openxmlformats.org/drawingml/2006/main"/>
           <a:p xmlns:a="http://schemas.openxmlformats.org/drawingml/2006/main">
             <a:pPr algn="l">
+              <a:buNone/>
               <a:defRPr sz="600" b="0">
                 <a:solidFill>
                   <a:srgbClr val="89A59F"/>
@@ -7417,6 +7479,7 @@
           </a:p>
           <a:p xmlns:a="http://schemas.openxmlformats.org/drawingml/2006/main">
             <a:pPr algn="l">
+              <a:buNone/>
               <a:defRPr sz="600" b="0">
                 <a:solidFill>
                   <a:srgbClr val="89A59F"/>
@@ -7502,6 +7565,7 @@
           <a:lstStyle xmlns:a="http://schemas.openxmlformats.org/drawingml/2006/main"/>
           <a:p xmlns:a="http://schemas.openxmlformats.org/drawingml/2006/main">
             <a:pPr algn="l">
+              <a:buNone/>
               <a:defRPr sz="690" b="1">
                 <a:solidFill>
                   <a:srgbClr val="F0FAF8"/>
@@ -7552,6 +7616,7 @@
           <a:lstStyle xmlns:a="http://schemas.openxmlformats.org/drawingml/2006/main"/>
           <a:p xmlns:a="http://schemas.openxmlformats.org/drawingml/2006/main">
             <a:pPr algn="l">
+              <a:buNone/>
               <a:defRPr sz="600" b="0">
                 <a:solidFill>
                   <a:srgbClr val="89A59F"/>
@@ -7569,6 +7634,7 @@
           </a:p>
           <a:p xmlns:a="http://schemas.openxmlformats.org/drawingml/2006/main">
             <a:pPr algn="l">
+              <a:buNone/>
               <a:defRPr sz="600" b="0">
                 <a:solidFill>
                   <a:srgbClr val="89A59F"/>
@@ -7654,6 +7720,7 @@
           <a:lstStyle xmlns:a="http://schemas.openxmlformats.org/drawingml/2006/main"/>
           <a:p xmlns:a="http://schemas.openxmlformats.org/drawingml/2006/main">
             <a:pPr algn="ctr">
+              <a:buNone/>
               <a:defRPr sz="660" b="1">
                 <a:solidFill>
                   <a:srgbClr val="F0FAF8"/>
@@ -7704,6 +7771,7 @@
           <a:lstStyle xmlns:a="http://schemas.openxmlformats.org/drawingml/2006/main"/>
           <a:p xmlns:a="http://schemas.openxmlformats.org/drawingml/2006/main">
             <a:pPr algn="ctr">
+              <a:buNone/>
               <a:defRPr sz="563" b="0">
                 <a:solidFill>
                   <a:srgbClr val="89A59F"/>
@@ -7721,6 +7789,7 @@
           </a:p>
           <a:p xmlns:a="http://schemas.openxmlformats.org/drawingml/2006/main">
             <a:pPr algn="ctr">
+              <a:buNone/>
               <a:defRPr sz="563" b="0">
                 <a:solidFill>
                   <a:srgbClr val="89A59F"/>
@@ -7771,6 +7840,7 @@
           <a:lstStyle xmlns:a="http://schemas.openxmlformats.org/drawingml/2006/main"/>
           <a:p xmlns:a="http://schemas.openxmlformats.org/drawingml/2006/main">
             <a:pPr algn="l">
+              <a:buNone/>
               <a:defRPr sz="600" b="1">
                 <a:solidFill>
                   <a:srgbClr val="89A59F"/>
@@ -7827,6 +7897,7 @@
           <a:lstStyle xmlns:a="http://schemas.openxmlformats.org/drawingml/2006/main"/>
           <a:p xmlns:a="http://schemas.openxmlformats.org/drawingml/2006/main">
             <a:pPr algn="ctr">
+              <a:buNone/>
               <a:defRPr sz="525" b="1">
                 <a:solidFill>
                   <a:srgbClr val="06100F"/>
@@ -7950,6 +8021,7 @@
           <a:lstStyle xmlns:a="http://schemas.openxmlformats.org/drawingml/2006/main"/>
           <a:p xmlns:a="http://schemas.openxmlformats.org/drawingml/2006/main">
             <a:pPr algn="l">
+              <a:buNone/>
               <a:defRPr sz="765" b="0">
                 <a:solidFill>
                   <a:srgbClr val="F0FAF8"/>
@@ -8006,6 +8078,7 @@
           <a:lstStyle xmlns:a="http://schemas.openxmlformats.org/drawingml/2006/main"/>
           <a:p xmlns:a="http://schemas.openxmlformats.org/drawingml/2006/main">
             <a:pPr algn="ctr">
+              <a:buNone/>
               <a:defRPr sz="525" b="1">
                 <a:solidFill>
                   <a:srgbClr val="06100F"/>
@@ -8129,6 +8202,7 @@
           <a:lstStyle xmlns:a="http://schemas.openxmlformats.org/drawingml/2006/main"/>
           <a:p xmlns:a="http://schemas.openxmlformats.org/drawingml/2006/main">
             <a:pPr algn="l">
+              <a:buNone/>
               <a:defRPr sz="765" b="0">
                 <a:solidFill>
                   <a:srgbClr val="F0FAF8"/>
@@ -8185,6 +8259,7 @@
           <a:lstStyle xmlns:a="http://schemas.openxmlformats.org/drawingml/2006/main"/>
           <a:p xmlns:a="http://schemas.openxmlformats.org/drawingml/2006/main">
             <a:pPr algn="ctr">
+              <a:buNone/>
               <a:defRPr sz="525" b="1">
                 <a:solidFill>
                   <a:srgbClr val="06100F"/>
@@ -8308,6 +8383,7 @@
           <a:lstStyle xmlns:a="http://schemas.openxmlformats.org/drawingml/2006/main"/>
           <a:p xmlns:a="http://schemas.openxmlformats.org/drawingml/2006/main">
             <a:pPr algn="l">
+              <a:buNone/>
               <a:defRPr sz="765" b="0">
                 <a:solidFill>
                   <a:srgbClr val="F0FAF8"/>
@@ -8364,6 +8440,7 @@
           <a:lstStyle xmlns:a="http://schemas.openxmlformats.org/drawingml/2006/main"/>
           <a:p xmlns:a="http://schemas.openxmlformats.org/drawingml/2006/main">
             <a:pPr algn="ctr">
+              <a:buNone/>
               <a:defRPr sz="525" b="1">
                 <a:solidFill>
                   <a:srgbClr val="06100F"/>
@@ -8487,6 +8564,7 @@
           <a:lstStyle xmlns:a="http://schemas.openxmlformats.org/drawingml/2006/main"/>
           <a:p xmlns:a="http://schemas.openxmlformats.org/drawingml/2006/main">
             <a:pPr algn="l">
+              <a:buNone/>
               <a:defRPr sz="765" b="0">
                 <a:solidFill>
                   <a:srgbClr val="F0FAF8"/>
@@ -8543,6 +8621,7 @@
           <a:lstStyle xmlns:a="http://schemas.openxmlformats.org/drawingml/2006/main"/>
           <a:p xmlns:a="http://schemas.openxmlformats.org/drawingml/2006/main">
             <a:pPr algn="ctr">
+              <a:buNone/>
               <a:defRPr sz="525" b="1">
                 <a:solidFill>
                   <a:srgbClr val="06100F"/>
@@ -8666,6 +8745,7 @@
           <a:lstStyle xmlns:a="http://schemas.openxmlformats.org/drawingml/2006/main"/>
           <a:p xmlns:a="http://schemas.openxmlformats.org/drawingml/2006/main">
             <a:pPr algn="l">
+              <a:buNone/>
               <a:defRPr sz="765" b="0">
                 <a:solidFill>
                   <a:srgbClr val="F0FAF8"/>
@@ -8716,6 +8796,7 @@
           <a:lstStyle xmlns:a="http://schemas.openxmlformats.org/drawingml/2006/main"/>
           <a:p xmlns:a="http://schemas.openxmlformats.org/drawingml/2006/main">
             <a:pPr algn="l">
+              <a:buNone/>
               <a:defRPr sz="675" b="1">
                 <a:solidFill>
                   <a:srgbClr val="E8A94D"/>
@@ -8766,6 +8847,7 @@
           <a:lstStyle xmlns:a="http://schemas.openxmlformats.org/drawingml/2006/main"/>
           <a:p xmlns:a="http://schemas.openxmlformats.org/drawingml/2006/main">
             <a:pPr algn="ctr">
+              <a:buNone/>
               <a:defRPr sz="675" b="0">
                 <a:solidFill>
                   <a:srgbClr val="89A59F"/>
@@ -8816,6 +8898,7 @@
           <a:lstStyle xmlns:a="http://schemas.openxmlformats.org/drawingml/2006/main"/>
           <a:p xmlns:a="http://schemas.openxmlformats.org/drawingml/2006/main">
             <a:pPr algn="r">
+              <a:buNone/>
               <a:defRPr sz="600" b="0">
                 <a:solidFill>
                   <a:srgbClr val="24E6BD"/>

</xml_diff>

<commit_message>
Restore the PedestrianTracker identity-review demo
Rebuilds the standalone EffiPed portfolio around the original PedestrianTracker identity-review workflow, real tracker-rendered replay media, reconciled evidence, responsive UI, and updated research/report assets.
</commit_message>
<xml_diff>
--- a/docs/architecture/effiped-architecture.pptx
+++ b/docs/architecture/effiped-architecture.pptx
@@ -2,13 +2,13 @@
 <file path=ppt/presentation.xml><?xml version="1.0" encoding="utf-8"?>
 <p:presentation xmlns:p="http://schemas.openxmlformats.org/presentationml/2006/main">
   <p:sldMasterIdLst>
-    <p:sldMasterId xmlns:r="http://schemas.openxmlformats.org/officeDocument/2006/relationships" id="2147483648" r:id="R985965567851485b"/>
+    <p:sldMasterId xmlns:r="http://schemas.openxmlformats.org/officeDocument/2006/relationships" id="2147483648" r:id="R7a70475cc8504178"/>
   </p:sldMasterIdLst>
   <p:notesMasterIdLst>
-    <p:notesMasterId xmlns:r="http://schemas.openxmlformats.org/officeDocument/2006/relationships" r:id="R78e09e8821b946cc"/>
+    <p:notesMasterId xmlns:r="http://schemas.openxmlformats.org/officeDocument/2006/relationships" r:id="R177627860b1042bd"/>
   </p:notesMasterIdLst>
   <p:sldIdLst>
-    <p:sldId xmlns:r="http://schemas.openxmlformats.org/officeDocument/2006/relationships" id="256" r:id="R8e52244622d445a2"/>
+    <p:sldId xmlns:r="http://schemas.openxmlformats.org/officeDocument/2006/relationships" id="256" r:id="Ra46c8a6eb304482e"/>
   </p:sldIdLst>
   <p:sldSz cx="12192000" cy="6858000"/>
   <p:notesSz cx="6858000" cy="9144000"/>
@@ -447,22 +447,17 @@
           </a:p>
           <a:p xmlns:a="http://schemas.openxmlformats.org/drawingml/2006/main">
             <a:r>
-              <a:t>- EffiPed implementation and configurations: this repository, src/effiped and configs/contest.</a:t>
-            </a:r>
-          </a:p>
-          <a:p xmlns:a="http://schemas.openxmlformats.org/drawingml/2006/main">
-            <a:r>
-              <a:t>- Evidence fixture: research/results/summary.json.</a:t>
-            </a:r>
-          </a:p>
-          <a:p xmlns:a="http://schemas.openxmlformats.org/drawingml/2006/main">
-            <a:r>
-              <a:t>- P-DESTRE paper: https://arxiv.org/abs/2004.02782</a:t>
-            </a:r>
-          </a:p>
-          <a:p xmlns:a="http://schemas.openxmlformats.org/drawingml/2006/main">
-            <a:r>
-              <a:t>- Diagram equations are editable PowerPoint text using Cambria Math; notation summarizes implemented losses and retrieval.</a:t>
+              <a:t>- Project architecture and model configuration: repository source and configs/system/effiped-tier1.yaml</a:t>
+            </a:r>
+          </a:p>
+          <a:p xmlns:a="http://schemas.openxmlformats.org/drawingml/2006/main">
+            <a:r>
+              <a:t>- Aggregate evidence: research/results/summary.json</a:t>
+            </a:r>
+          </a:p>
+          <a:p xmlns:a="http://schemas.openxmlformats.org/drawingml/2006/main">
+            <a:r>
+              <a:t>[/Sources]</a:t>
             </a:r>
           </a:p>
         </p:txBody>
@@ -530,7 +525,7 @@
   </p:cSld>
   <p:clrMap bg1="lt1" tx1="dk1" bg2="lt2" tx2="dk2" accent1="accent1" accent2="accent2" accent3="accent3" accent4="accent4" accent5="accent5" accent6="accent6" hlink="hlink" folHlink="folHlink"/>
   <p:sldLayoutIdLst>
-    <p:sldLayoutId xmlns:r="http://schemas.openxmlformats.org/officeDocument/2006/relationships" id="2147483649" r:id="Ra3b5543d4cb645ca"/>
+    <p:sldLayoutId xmlns:r="http://schemas.openxmlformats.org/officeDocument/2006/relationships" id="2147483649" r:id="R29a3d2c9a4f24a7c"/>
   </p:sldLayoutIdLst>
   <p:txStyles>
     <p:titleStyle>
@@ -3699,6 +3694,7 @@
           <a:lstStyle xmlns:a="http://schemas.openxmlformats.org/drawingml/2006/main"/>
           <a:p xmlns:a="http://schemas.openxmlformats.org/drawingml/2006/main">
             <a:pPr algn="l">
+              <a:buNone/>
               <a:defRPr sz="750" b="1">
                 <a:solidFill>
                   <a:srgbClr val="24E6BD"/>
@@ -3749,6 +3745,7 @@
           <a:lstStyle xmlns:a="http://schemas.openxmlformats.org/drawingml/2006/main"/>
           <a:p xmlns:a="http://schemas.openxmlformats.org/drawingml/2006/main">
             <a:pPr algn="l">
+              <a:buNone/>
               <a:defRPr sz="1650" b="1">
                 <a:solidFill>
                   <a:srgbClr val="F0FAF8"/>
@@ -3805,6 +3802,7 @@
           <a:lstStyle xmlns:a="http://schemas.openxmlformats.org/drawingml/2006/main"/>
           <a:p xmlns:a="http://schemas.openxmlformats.org/drawingml/2006/main">
             <a:pPr algn="ctr">
+              <a:buNone/>
               <a:defRPr sz="525" b="1">
                 <a:solidFill>
                   <a:srgbClr val="06100F"/>
@@ -3817,7 +3815,7 @@
                   <a:srgbClr val="06100F"/>
                 </a:solidFill>
               </a:rPr>
-              <a:t>3RD PRIZE · SIPC 2026</a:t>
+              <a:t>DETECTION · TRACKING · RETRIEVAL</a:t>
             </a:r>
           </a:p>
         </p:txBody>
@@ -3855,6 +3853,7 @@
           <a:lstStyle xmlns:a="http://schemas.openxmlformats.org/drawingml/2006/main"/>
           <a:p xmlns:a="http://schemas.openxmlformats.org/drawingml/2006/main">
             <a:pPr algn="l">
+              <a:buNone/>
               <a:defRPr sz="600" b="1">
                 <a:solidFill>
                   <a:srgbClr val="89A59F"/>
@@ -3940,6 +3939,7 @@
           <a:lstStyle xmlns:a="http://schemas.openxmlformats.org/drawingml/2006/main"/>
           <a:p xmlns:a="http://schemas.openxmlformats.org/drawingml/2006/main">
             <a:pPr algn="ctr">
+              <a:buNone/>
               <a:defRPr sz="900" b="1">
                 <a:solidFill>
                   <a:srgbClr val="F0FAF8"/>
@@ -3990,6 +3990,7 @@
           <a:lstStyle xmlns:a="http://schemas.openxmlformats.org/drawingml/2006/main"/>
           <a:p xmlns:a="http://schemas.openxmlformats.org/drawingml/2006/main">
             <a:pPr algn="ctr">
+              <a:buNone/>
               <a:defRPr sz="525" b="0">
                 <a:solidFill>
                   <a:srgbClr val="89A59F"/>
@@ -4108,6 +4109,7 @@
           <a:lstStyle xmlns:a="http://schemas.openxmlformats.org/drawingml/2006/main"/>
           <a:p xmlns:a="http://schemas.openxmlformats.org/drawingml/2006/main">
             <a:pPr algn="ctr">
+              <a:buNone/>
               <a:defRPr sz="900" b="1">
                 <a:solidFill>
                   <a:srgbClr val="F0FAF8"/>
@@ -4158,6 +4160,7 @@
           <a:lstStyle xmlns:a="http://schemas.openxmlformats.org/drawingml/2006/main"/>
           <a:p xmlns:a="http://schemas.openxmlformats.org/drawingml/2006/main">
             <a:pPr algn="ctr">
+              <a:buNone/>
               <a:defRPr sz="525" b="0">
                 <a:solidFill>
                   <a:srgbClr val="89A59F"/>
@@ -4276,6 +4279,7 @@
           <a:lstStyle xmlns:a="http://schemas.openxmlformats.org/drawingml/2006/main"/>
           <a:p xmlns:a="http://schemas.openxmlformats.org/drawingml/2006/main">
             <a:pPr algn="ctr">
+              <a:buNone/>
               <a:defRPr sz="900" b="1">
                 <a:solidFill>
                   <a:srgbClr val="F0FAF8"/>
@@ -4326,6 +4330,7 @@
           <a:lstStyle xmlns:a="http://schemas.openxmlformats.org/drawingml/2006/main"/>
           <a:p xmlns:a="http://schemas.openxmlformats.org/drawingml/2006/main">
             <a:pPr algn="ctr">
+              <a:buNone/>
               <a:defRPr sz="525" b="0">
                 <a:solidFill>
                   <a:srgbClr val="89A59F"/>
@@ -4444,6 +4449,7 @@
           <a:lstStyle xmlns:a="http://schemas.openxmlformats.org/drawingml/2006/main"/>
           <a:p xmlns:a="http://schemas.openxmlformats.org/drawingml/2006/main">
             <a:pPr algn="ctr">
+              <a:buNone/>
               <a:defRPr sz="900" b="1">
                 <a:solidFill>
                   <a:srgbClr val="F0FAF8"/>
@@ -4494,6 +4500,7 @@
           <a:lstStyle xmlns:a="http://schemas.openxmlformats.org/drawingml/2006/main"/>
           <a:p xmlns:a="http://schemas.openxmlformats.org/drawingml/2006/main">
             <a:pPr algn="ctr">
+              <a:buNone/>
               <a:defRPr sz="525" b="0">
                 <a:solidFill>
                   <a:srgbClr val="89A59F"/>
@@ -4612,6 +4619,7 @@
           <a:lstStyle xmlns:a="http://schemas.openxmlformats.org/drawingml/2006/main"/>
           <a:p xmlns:a="http://schemas.openxmlformats.org/drawingml/2006/main">
             <a:pPr algn="l">
+              <a:buNone/>
               <a:defRPr sz="750" b="1">
                 <a:solidFill>
                   <a:srgbClr val="F0FAF8"/>
@@ -4662,6 +4670,7 @@
           <a:lstStyle xmlns:a="http://schemas.openxmlformats.org/drawingml/2006/main"/>
           <a:p xmlns:a="http://schemas.openxmlformats.org/drawingml/2006/main">
             <a:pPr algn="l">
+              <a:buNone/>
               <a:defRPr sz="563" b="0">
                 <a:solidFill>
                   <a:srgbClr val="89A59F"/>
@@ -4679,6 +4688,7 @@
           </a:p>
           <a:p xmlns:a="http://schemas.openxmlformats.org/drawingml/2006/main">
             <a:pPr algn="l">
+              <a:buNone/>
               <a:defRPr sz="563" b="0">
                 <a:solidFill>
                   <a:srgbClr val="89A59F"/>
@@ -4729,6 +4739,7 @@
           <a:lstStyle xmlns:a="http://schemas.openxmlformats.org/drawingml/2006/main"/>
           <a:p xmlns:a="http://schemas.openxmlformats.org/drawingml/2006/main">
             <a:pPr algn="l">
+              <a:buNone/>
               <a:defRPr sz="600" b="1">
                 <a:solidFill>
                   <a:srgbClr val="89A59F"/>
@@ -4814,6 +4825,7 @@
           <a:lstStyle xmlns:a="http://schemas.openxmlformats.org/drawingml/2006/main"/>
           <a:p xmlns:a="http://schemas.openxmlformats.org/drawingml/2006/main">
             <a:pPr algn="l">
+              <a:buNone/>
               <a:defRPr sz="825" b="1">
                 <a:solidFill>
                   <a:srgbClr val="F0FAF8"/>
@@ -4899,6 +4911,7 @@
           <a:lstStyle xmlns:a="http://schemas.openxmlformats.org/drawingml/2006/main"/>
           <a:p xmlns:a="http://schemas.openxmlformats.org/drawingml/2006/main">
             <a:pPr algn="ctr">
+              <a:buNone/>
               <a:defRPr sz="503" b="0">
                 <a:solidFill>
                   <a:srgbClr val="F0FAF8"/>
@@ -4984,6 +4997,7 @@
           <a:lstStyle xmlns:a="http://schemas.openxmlformats.org/drawingml/2006/main"/>
           <a:p xmlns:a="http://schemas.openxmlformats.org/drawingml/2006/main">
             <a:pPr algn="ctr">
+              <a:buNone/>
               <a:defRPr sz="503" b="0">
                 <a:solidFill>
                   <a:srgbClr val="F0FAF8"/>
@@ -5069,6 +5083,7 @@
           <a:lstStyle xmlns:a="http://schemas.openxmlformats.org/drawingml/2006/main"/>
           <a:p xmlns:a="http://schemas.openxmlformats.org/drawingml/2006/main">
             <a:pPr algn="ctr">
+              <a:buNone/>
               <a:defRPr sz="503" b="0">
                 <a:solidFill>
                   <a:srgbClr val="F0FAF8"/>
@@ -5154,6 +5169,7 @@
           <a:lstStyle xmlns:a="http://schemas.openxmlformats.org/drawingml/2006/main"/>
           <a:p xmlns:a="http://schemas.openxmlformats.org/drawingml/2006/main">
             <a:pPr algn="ctr">
+              <a:buNone/>
               <a:defRPr sz="503" b="0">
                 <a:solidFill>
                   <a:srgbClr val="F0FAF8"/>
@@ -5239,6 +5255,7 @@
           <a:lstStyle xmlns:a="http://schemas.openxmlformats.org/drawingml/2006/main"/>
           <a:p xmlns:a="http://schemas.openxmlformats.org/drawingml/2006/main">
             <a:pPr algn="l">
+              <a:buNone/>
               <a:defRPr sz="825" b="1">
                 <a:solidFill>
                   <a:srgbClr val="F0FAF8"/>
@@ -5289,6 +5306,7 @@
           <a:lstStyle xmlns:a="http://schemas.openxmlformats.org/drawingml/2006/main"/>
           <a:p xmlns:a="http://schemas.openxmlformats.org/drawingml/2006/main">
             <a:pPr algn="l">
+              <a:buNone/>
               <a:defRPr sz="615" b="0">
                 <a:solidFill>
                   <a:srgbClr val="89A59F"/>
@@ -5306,6 +5324,7 @@
           </a:p>
           <a:p xmlns:a="http://schemas.openxmlformats.org/drawingml/2006/main">
             <a:pPr algn="l">
+              <a:buNone/>
               <a:defRPr sz="615" b="0">
                 <a:solidFill>
                   <a:srgbClr val="89A59F"/>
@@ -5323,6 +5342,7 @@
           </a:p>
           <a:p xmlns:a="http://schemas.openxmlformats.org/drawingml/2006/main">
             <a:pPr algn="l">
+              <a:buNone/>
               <a:defRPr sz="615" b="0">
                 <a:solidFill>
                   <a:srgbClr val="89A59F"/>
@@ -5373,6 +5393,7 @@
           <a:lstStyle xmlns:a="http://schemas.openxmlformats.org/drawingml/2006/main"/>
           <a:p xmlns:a="http://schemas.openxmlformats.org/drawingml/2006/main">
             <a:pPr algn="l">
+              <a:buNone/>
               <a:defRPr sz="600" b="1">
                 <a:solidFill>
                   <a:srgbClr val="89A59F"/>
@@ -5458,6 +5479,7 @@
           <a:lstStyle xmlns:a="http://schemas.openxmlformats.org/drawingml/2006/main"/>
           <a:p xmlns:a="http://schemas.openxmlformats.org/drawingml/2006/main">
             <a:pPr algn="l">
+              <a:buNone/>
               <a:defRPr sz="825" b="1">
                 <a:solidFill>
                   <a:srgbClr val="F0FAF8"/>
@@ -5508,6 +5530,7 @@
           <a:lstStyle xmlns:a="http://schemas.openxmlformats.org/drawingml/2006/main"/>
           <a:p xmlns:a="http://schemas.openxmlformats.org/drawingml/2006/main">
             <a:pPr algn="l">
+              <a:buNone/>
               <a:defRPr sz="607" b="0">
                 <a:solidFill>
                   <a:srgbClr val="89A59F"/>
@@ -5525,6 +5548,7 @@
           </a:p>
           <a:p xmlns:a="http://schemas.openxmlformats.org/drawingml/2006/main">
             <a:pPr algn="l">
+              <a:buNone/>
               <a:defRPr sz="607" b="0">
                 <a:solidFill>
                   <a:srgbClr val="89A59F"/>
@@ -5542,6 +5566,7 @@
           </a:p>
           <a:p xmlns:a="http://schemas.openxmlformats.org/drawingml/2006/main">
             <a:pPr algn="l">
+              <a:buNone/>
               <a:defRPr sz="607" b="0">
                 <a:solidFill>
                   <a:srgbClr val="89A59F"/>
@@ -5559,6 +5584,7 @@
           </a:p>
           <a:p xmlns:a="http://schemas.openxmlformats.org/drawingml/2006/main">
             <a:pPr algn="l">
+              <a:buNone/>
               <a:defRPr sz="607" b="0">
                 <a:solidFill>
                   <a:srgbClr val="89A59F"/>
@@ -5609,6 +5635,7 @@
           <a:lstStyle xmlns:a="http://schemas.openxmlformats.org/drawingml/2006/main"/>
           <a:p xmlns:a="http://schemas.openxmlformats.org/drawingml/2006/main">
             <a:pPr algn="ctr">
+              <a:buNone/>
               <a:defRPr sz="600" b="0">
                 <a:solidFill>
                   <a:srgbClr val="8CF8DF"/>
@@ -5626,6 +5653,7 @@
           </a:p>
           <a:p xmlns:a="http://schemas.openxmlformats.org/drawingml/2006/main">
             <a:pPr algn="ctr">
+              <a:buNone/>
               <a:defRPr sz="600" b="0">
                 <a:solidFill>
                   <a:srgbClr val="8CF8DF"/>
@@ -5676,6 +5704,7 @@
           <a:lstStyle xmlns:a="http://schemas.openxmlformats.org/drawingml/2006/main"/>
           <a:p xmlns:a="http://schemas.openxmlformats.org/drawingml/2006/main">
             <a:pPr algn="l">
+              <a:buNone/>
               <a:defRPr sz="600" b="1">
                 <a:solidFill>
                   <a:srgbClr val="89A59F"/>
@@ -5761,6 +5790,7 @@
           <a:lstStyle xmlns:a="http://schemas.openxmlformats.org/drawingml/2006/main"/>
           <a:p xmlns:a="http://schemas.openxmlformats.org/drawingml/2006/main">
             <a:pPr algn="l">
+              <a:buNone/>
               <a:defRPr sz="825" b="1">
                 <a:solidFill>
                   <a:srgbClr val="F0FAF8"/>
@@ -5811,6 +5841,7 @@
           <a:lstStyle xmlns:a="http://schemas.openxmlformats.org/drawingml/2006/main"/>
           <a:p xmlns:a="http://schemas.openxmlformats.org/drawingml/2006/main">
             <a:pPr algn="l">
+              <a:buNone/>
               <a:defRPr sz="653" b="0">
                 <a:solidFill>
                   <a:srgbClr val="89A59F"/>
@@ -5828,6 +5859,7 @@
           </a:p>
           <a:p xmlns:a="http://schemas.openxmlformats.org/drawingml/2006/main">
             <a:pPr algn="l">
+              <a:buNone/>
               <a:defRPr sz="653" b="0">
                 <a:solidFill>
                   <a:srgbClr val="89A59F"/>
@@ -5845,6 +5877,7 @@
           </a:p>
           <a:p xmlns:a="http://schemas.openxmlformats.org/drawingml/2006/main">
             <a:pPr algn="l">
+              <a:buNone/>
               <a:defRPr sz="653" b="0">
                 <a:solidFill>
                   <a:srgbClr val="89A59F"/>
@@ -5862,6 +5895,7 @@
           </a:p>
           <a:p xmlns:a="http://schemas.openxmlformats.org/drawingml/2006/main">
             <a:pPr algn="l">
+              <a:buNone/>
               <a:defRPr sz="653" b="0">
                 <a:solidFill>
                   <a:srgbClr val="89A59F"/>
@@ -5947,6 +5981,7 @@
           <a:lstStyle xmlns:a="http://schemas.openxmlformats.org/drawingml/2006/main"/>
           <a:p xmlns:a="http://schemas.openxmlformats.org/drawingml/2006/main">
             <a:pPr algn="l">
+              <a:buNone/>
               <a:defRPr sz="825" b="1">
                 <a:solidFill>
                   <a:srgbClr val="F0FAF8"/>
@@ -5997,6 +6032,7 @@
           <a:lstStyle xmlns:a="http://schemas.openxmlformats.org/drawingml/2006/main"/>
           <a:p xmlns:a="http://schemas.openxmlformats.org/drawingml/2006/main">
             <a:pPr algn="l">
+              <a:buNone/>
               <a:defRPr sz="630" b="0">
                 <a:solidFill>
                   <a:srgbClr val="89A59F"/>
@@ -6014,6 +6050,7 @@
           </a:p>
           <a:p xmlns:a="http://schemas.openxmlformats.org/drawingml/2006/main">
             <a:pPr algn="l">
+              <a:buNone/>
               <a:defRPr sz="630" b="0">
                 <a:solidFill>
                   <a:srgbClr val="89A59F"/>
@@ -6196,6 +6233,7 @@
           <a:lstStyle xmlns:a="http://schemas.openxmlformats.org/drawingml/2006/main"/>
           <a:p xmlns:a="http://schemas.openxmlformats.org/drawingml/2006/main">
             <a:pPr algn="l">
+              <a:buNone/>
               <a:defRPr sz="600" b="1">
                 <a:solidFill>
                   <a:srgbClr val="89A59F"/>
@@ -6281,6 +6319,7 @@
           <a:lstStyle xmlns:a="http://schemas.openxmlformats.org/drawingml/2006/main"/>
           <a:p xmlns:a="http://schemas.openxmlformats.org/drawingml/2006/main">
             <a:pPr algn="l">
+              <a:buNone/>
               <a:defRPr sz="825" b="1">
                 <a:solidFill>
                   <a:srgbClr val="F0FAF8"/>
@@ -6331,6 +6370,7 @@
           <a:lstStyle xmlns:a="http://schemas.openxmlformats.org/drawingml/2006/main"/>
           <a:p xmlns:a="http://schemas.openxmlformats.org/drawingml/2006/main">
             <a:pPr algn="l">
+              <a:buNone/>
               <a:defRPr sz="630" b="0">
                 <a:solidFill>
                   <a:srgbClr val="89A59F"/>
@@ -6348,6 +6388,7 @@
           </a:p>
           <a:p xmlns:a="http://schemas.openxmlformats.org/drawingml/2006/main">
             <a:pPr algn="l">
+              <a:buNone/>
               <a:defRPr sz="630" b="0">
                 <a:solidFill>
                   <a:srgbClr val="89A59F"/>
@@ -6365,6 +6406,7 @@
           </a:p>
           <a:p xmlns:a="http://schemas.openxmlformats.org/drawingml/2006/main">
             <a:pPr algn="l">
+              <a:buNone/>
               <a:defRPr sz="630" b="0">
                 <a:solidFill>
                   <a:srgbClr val="89A59F"/>
@@ -6382,6 +6424,7 @@
           </a:p>
           <a:p xmlns:a="http://schemas.openxmlformats.org/drawingml/2006/main">
             <a:pPr algn="l">
+              <a:buNone/>
               <a:defRPr sz="630" b="0">
                 <a:solidFill>
                   <a:srgbClr val="89A59F"/>
@@ -6556,6 +6599,7 @@
           <a:lstStyle xmlns:a="http://schemas.openxmlformats.org/drawingml/2006/main"/>
           <a:p xmlns:a="http://schemas.openxmlformats.org/drawingml/2006/main">
             <a:pPr algn="l">
+              <a:buNone/>
               <a:defRPr sz="600" b="1">
                 <a:solidFill>
                   <a:srgbClr val="89A59F"/>
@@ -6641,6 +6685,7 @@
           <a:lstStyle xmlns:a="http://schemas.openxmlformats.org/drawingml/2006/main"/>
           <a:p xmlns:a="http://schemas.openxmlformats.org/drawingml/2006/main">
             <a:pPr algn="l">
+              <a:buNone/>
               <a:defRPr sz="825" b="1">
                 <a:solidFill>
                   <a:srgbClr val="F0FAF8"/>
@@ -6691,6 +6736,7 @@
           <a:lstStyle xmlns:a="http://schemas.openxmlformats.org/drawingml/2006/main"/>
           <a:p xmlns:a="http://schemas.openxmlformats.org/drawingml/2006/main">
             <a:pPr algn="l">
+              <a:buNone/>
               <a:defRPr sz="607" b="0">
                 <a:solidFill>
                   <a:srgbClr val="89A59F"/>
@@ -6708,6 +6754,7 @@
           </a:p>
           <a:p xmlns:a="http://schemas.openxmlformats.org/drawingml/2006/main">
             <a:pPr algn="l">
+              <a:buNone/>
               <a:defRPr sz="607" b="0">
                 <a:solidFill>
                   <a:srgbClr val="89A59F"/>
@@ -6725,6 +6772,7 @@
           </a:p>
           <a:p xmlns:a="http://schemas.openxmlformats.org/drawingml/2006/main">
             <a:pPr algn="l">
+              <a:buNone/>
               <a:defRPr sz="607" b="0">
                 <a:solidFill>
                   <a:srgbClr val="89A59F"/>
@@ -6742,6 +6790,7 @@
           </a:p>
           <a:p xmlns:a="http://schemas.openxmlformats.org/drawingml/2006/main">
             <a:pPr algn="l">
+              <a:buNone/>
               <a:defRPr sz="607" b="0">
                 <a:solidFill>
                   <a:srgbClr val="89A59F"/>
@@ -6827,6 +6876,7 @@
           <a:lstStyle xmlns:a="http://schemas.openxmlformats.org/drawingml/2006/main"/>
           <a:p xmlns:a="http://schemas.openxmlformats.org/drawingml/2006/main">
             <a:pPr algn="ctr">
+              <a:buNone/>
               <a:defRPr sz="713" b="1">
                 <a:solidFill>
                   <a:srgbClr val="F0FAF8"/>
@@ -6877,6 +6927,7 @@
           <a:lstStyle xmlns:a="http://schemas.openxmlformats.org/drawingml/2006/main"/>
           <a:p xmlns:a="http://schemas.openxmlformats.org/drawingml/2006/main">
             <a:pPr algn="ctr">
+              <a:buNone/>
               <a:defRPr sz="555" b="0">
                 <a:solidFill>
                   <a:srgbClr val="89A59F"/>
@@ -6894,6 +6945,7 @@
           </a:p>
           <a:p xmlns:a="http://schemas.openxmlformats.org/drawingml/2006/main">
             <a:pPr algn="ctr">
+              <a:buNone/>
               <a:defRPr sz="555" b="0">
                 <a:solidFill>
                   <a:srgbClr val="89A59F"/>
@@ -6911,6 +6963,7 @@
           </a:p>
           <a:p xmlns:a="http://schemas.openxmlformats.org/drawingml/2006/main">
             <a:pPr algn="ctr">
+              <a:buNone/>
               <a:defRPr sz="555" b="0">
                 <a:solidFill>
                   <a:srgbClr val="89A59F"/>
@@ -6961,6 +7014,7 @@
           <a:lstStyle xmlns:a="http://schemas.openxmlformats.org/drawingml/2006/main"/>
           <a:p xmlns:a="http://schemas.openxmlformats.org/drawingml/2006/main">
             <a:pPr algn="l">
+              <a:buNone/>
               <a:defRPr sz="600" b="1">
                 <a:solidFill>
                   <a:srgbClr val="89A59F"/>
@@ -7046,6 +7100,7 @@
           <a:lstStyle xmlns:a="http://schemas.openxmlformats.org/drawingml/2006/main"/>
           <a:p xmlns:a="http://schemas.openxmlformats.org/drawingml/2006/main">
             <a:pPr algn="l">
+              <a:buNone/>
               <a:defRPr sz="750" b="1">
                 <a:solidFill>
                   <a:srgbClr val="F0FAF8"/>
@@ -7096,6 +7151,7 @@
           <a:lstStyle xmlns:a="http://schemas.openxmlformats.org/drawingml/2006/main"/>
           <a:p xmlns:a="http://schemas.openxmlformats.org/drawingml/2006/main">
             <a:pPr algn="l">
+              <a:buNone/>
               <a:defRPr sz="600" b="0">
                 <a:solidFill>
                   <a:srgbClr val="89A59F"/>
@@ -7113,6 +7169,7 @@
           </a:p>
           <a:p xmlns:a="http://schemas.openxmlformats.org/drawingml/2006/main">
             <a:pPr algn="l">
+              <a:buNone/>
               <a:defRPr sz="600" b="0">
                 <a:solidFill>
                   <a:srgbClr val="89A59F"/>
@@ -7198,6 +7255,7 @@
           <a:lstStyle xmlns:a="http://schemas.openxmlformats.org/drawingml/2006/main"/>
           <a:p xmlns:a="http://schemas.openxmlformats.org/drawingml/2006/main">
             <a:pPr algn="l">
+              <a:buNone/>
               <a:defRPr sz="750" b="1">
                 <a:solidFill>
                   <a:srgbClr val="F0FAF8"/>
@@ -7248,6 +7306,7 @@
           <a:lstStyle xmlns:a="http://schemas.openxmlformats.org/drawingml/2006/main"/>
           <a:p xmlns:a="http://schemas.openxmlformats.org/drawingml/2006/main">
             <a:pPr algn="l">
+              <a:buNone/>
               <a:defRPr sz="600" b="0">
                 <a:solidFill>
                   <a:srgbClr val="89A59F"/>
@@ -7265,6 +7324,7 @@
           </a:p>
           <a:p xmlns:a="http://schemas.openxmlformats.org/drawingml/2006/main">
             <a:pPr algn="l">
+              <a:buNone/>
               <a:defRPr sz="600" b="0">
                 <a:solidFill>
                   <a:srgbClr val="89A59F"/>
@@ -7350,6 +7410,7 @@
           <a:lstStyle xmlns:a="http://schemas.openxmlformats.org/drawingml/2006/main"/>
           <a:p xmlns:a="http://schemas.openxmlformats.org/drawingml/2006/main">
             <a:pPr algn="l">
+              <a:buNone/>
               <a:defRPr sz="690" b="1">
                 <a:solidFill>
                   <a:srgbClr val="F0FAF8"/>
@@ -7400,6 +7461,7 @@
           <a:lstStyle xmlns:a="http://schemas.openxmlformats.org/drawingml/2006/main"/>
           <a:p xmlns:a="http://schemas.openxmlformats.org/drawingml/2006/main">
             <a:pPr algn="l">
+              <a:buNone/>
               <a:defRPr sz="600" b="0">
                 <a:solidFill>
                   <a:srgbClr val="89A59F"/>
@@ -7417,6 +7479,7 @@
           </a:p>
           <a:p xmlns:a="http://schemas.openxmlformats.org/drawingml/2006/main">
             <a:pPr algn="l">
+              <a:buNone/>
               <a:defRPr sz="600" b="0">
                 <a:solidFill>
                   <a:srgbClr val="89A59F"/>
@@ -7502,6 +7565,7 @@
           <a:lstStyle xmlns:a="http://schemas.openxmlformats.org/drawingml/2006/main"/>
           <a:p xmlns:a="http://schemas.openxmlformats.org/drawingml/2006/main">
             <a:pPr algn="l">
+              <a:buNone/>
               <a:defRPr sz="690" b="1">
                 <a:solidFill>
                   <a:srgbClr val="F0FAF8"/>
@@ -7552,6 +7616,7 @@
           <a:lstStyle xmlns:a="http://schemas.openxmlformats.org/drawingml/2006/main"/>
           <a:p xmlns:a="http://schemas.openxmlformats.org/drawingml/2006/main">
             <a:pPr algn="l">
+              <a:buNone/>
               <a:defRPr sz="600" b="0">
                 <a:solidFill>
                   <a:srgbClr val="89A59F"/>
@@ -7569,6 +7634,7 @@
           </a:p>
           <a:p xmlns:a="http://schemas.openxmlformats.org/drawingml/2006/main">
             <a:pPr algn="l">
+              <a:buNone/>
               <a:defRPr sz="600" b="0">
                 <a:solidFill>
                   <a:srgbClr val="89A59F"/>
@@ -7654,6 +7720,7 @@
           <a:lstStyle xmlns:a="http://schemas.openxmlformats.org/drawingml/2006/main"/>
           <a:p xmlns:a="http://schemas.openxmlformats.org/drawingml/2006/main">
             <a:pPr algn="ctr">
+              <a:buNone/>
               <a:defRPr sz="660" b="1">
                 <a:solidFill>
                   <a:srgbClr val="F0FAF8"/>
@@ -7704,6 +7771,7 @@
           <a:lstStyle xmlns:a="http://schemas.openxmlformats.org/drawingml/2006/main"/>
           <a:p xmlns:a="http://schemas.openxmlformats.org/drawingml/2006/main">
             <a:pPr algn="ctr">
+              <a:buNone/>
               <a:defRPr sz="563" b="0">
                 <a:solidFill>
                   <a:srgbClr val="89A59F"/>
@@ -7721,6 +7789,7 @@
           </a:p>
           <a:p xmlns:a="http://schemas.openxmlformats.org/drawingml/2006/main">
             <a:pPr algn="ctr">
+              <a:buNone/>
               <a:defRPr sz="563" b="0">
                 <a:solidFill>
                   <a:srgbClr val="89A59F"/>
@@ -7771,6 +7840,7 @@
           <a:lstStyle xmlns:a="http://schemas.openxmlformats.org/drawingml/2006/main"/>
           <a:p xmlns:a="http://schemas.openxmlformats.org/drawingml/2006/main">
             <a:pPr algn="l">
+              <a:buNone/>
               <a:defRPr sz="600" b="1">
                 <a:solidFill>
                   <a:srgbClr val="89A59F"/>
@@ -7827,6 +7897,7 @@
           <a:lstStyle xmlns:a="http://schemas.openxmlformats.org/drawingml/2006/main"/>
           <a:p xmlns:a="http://schemas.openxmlformats.org/drawingml/2006/main">
             <a:pPr algn="ctr">
+              <a:buNone/>
               <a:defRPr sz="525" b="1">
                 <a:solidFill>
                   <a:srgbClr val="06100F"/>
@@ -7950,6 +8021,7 @@
           <a:lstStyle xmlns:a="http://schemas.openxmlformats.org/drawingml/2006/main"/>
           <a:p xmlns:a="http://schemas.openxmlformats.org/drawingml/2006/main">
             <a:pPr algn="l">
+              <a:buNone/>
               <a:defRPr sz="765" b="0">
                 <a:solidFill>
                   <a:srgbClr val="F0FAF8"/>
@@ -8006,6 +8078,7 @@
           <a:lstStyle xmlns:a="http://schemas.openxmlformats.org/drawingml/2006/main"/>
           <a:p xmlns:a="http://schemas.openxmlformats.org/drawingml/2006/main">
             <a:pPr algn="ctr">
+              <a:buNone/>
               <a:defRPr sz="525" b="1">
                 <a:solidFill>
                   <a:srgbClr val="06100F"/>
@@ -8129,6 +8202,7 @@
           <a:lstStyle xmlns:a="http://schemas.openxmlformats.org/drawingml/2006/main"/>
           <a:p xmlns:a="http://schemas.openxmlformats.org/drawingml/2006/main">
             <a:pPr algn="l">
+              <a:buNone/>
               <a:defRPr sz="765" b="0">
                 <a:solidFill>
                   <a:srgbClr val="F0FAF8"/>
@@ -8185,6 +8259,7 @@
           <a:lstStyle xmlns:a="http://schemas.openxmlformats.org/drawingml/2006/main"/>
           <a:p xmlns:a="http://schemas.openxmlformats.org/drawingml/2006/main">
             <a:pPr algn="ctr">
+              <a:buNone/>
               <a:defRPr sz="525" b="1">
                 <a:solidFill>
                   <a:srgbClr val="06100F"/>
@@ -8308,6 +8383,7 @@
           <a:lstStyle xmlns:a="http://schemas.openxmlformats.org/drawingml/2006/main"/>
           <a:p xmlns:a="http://schemas.openxmlformats.org/drawingml/2006/main">
             <a:pPr algn="l">
+              <a:buNone/>
               <a:defRPr sz="765" b="0">
                 <a:solidFill>
                   <a:srgbClr val="F0FAF8"/>
@@ -8364,6 +8440,7 @@
           <a:lstStyle xmlns:a="http://schemas.openxmlformats.org/drawingml/2006/main"/>
           <a:p xmlns:a="http://schemas.openxmlformats.org/drawingml/2006/main">
             <a:pPr algn="ctr">
+              <a:buNone/>
               <a:defRPr sz="525" b="1">
                 <a:solidFill>
                   <a:srgbClr val="06100F"/>
@@ -8487,6 +8564,7 @@
           <a:lstStyle xmlns:a="http://schemas.openxmlformats.org/drawingml/2006/main"/>
           <a:p xmlns:a="http://schemas.openxmlformats.org/drawingml/2006/main">
             <a:pPr algn="l">
+              <a:buNone/>
               <a:defRPr sz="765" b="0">
                 <a:solidFill>
                   <a:srgbClr val="F0FAF8"/>
@@ -8543,6 +8621,7 @@
           <a:lstStyle xmlns:a="http://schemas.openxmlformats.org/drawingml/2006/main"/>
           <a:p xmlns:a="http://schemas.openxmlformats.org/drawingml/2006/main">
             <a:pPr algn="ctr">
+              <a:buNone/>
               <a:defRPr sz="525" b="1">
                 <a:solidFill>
                   <a:srgbClr val="06100F"/>
@@ -8666,6 +8745,7 @@
           <a:lstStyle xmlns:a="http://schemas.openxmlformats.org/drawingml/2006/main"/>
           <a:p xmlns:a="http://schemas.openxmlformats.org/drawingml/2006/main">
             <a:pPr algn="l">
+              <a:buNone/>
               <a:defRPr sz="765" b="0">
                 <a:solidFill>
                   <a:srgbClr val="F0FAF8"/>
@@ -8716,6 +8796,7 @@
           <a:lstStyle xmlns:a="http://schemas.openxmlformats.org/drawingml/2006/main"/>
           <a:p xmlns:a="http://schemas.openxmlformats.org/drawingml/2006/main">
             <a:pPr algn="l">
+              <a:buNone/>
               <a:defRPr sz="675" b="1">
                 <a:solidFill>
                   <a:srgbClr val="E8A94D"/>
@@ -8766,6 +8847,7 @@
           <a:lstStyle xmlns:a="http://schemas.openxmlformats.org/drawingml/2006/main"/>
           <a:p xmlns:a="http://schemas.openxmlformats.org/drawingml/2006/main">
             <a:pPr algn="ctr">
+              <a:buNone/>
               <a:defRPr sz="675" b="0">
                 <a:solidFill>
                   <a:srgbClr val="89A59F"/>
@@ -8816,6 +8898,7 @@
           <a:lstStyle xmlns:a="http://schemas.openxmlformats.org/drawingml/2006/main"/>
           <a:p xmlns:a="http://schemas.openxmlformats.org/drawingml/2006/main">
             <a:pPr algn="r">
+              <a:buNone/>
               <a:defRPr sz="600" b="0">
                 <a:solidFill>
                   <a:srgbClr val="24E6BD"/>

</xml_diff>